<commit_message>
Informe del Sprint 1 en PDF y estado del sprint actualizado
Co-Authored-By: Claude Sonnet 5.5 <noreply@anthropic.com>
</commit_message>
<xml_diff>
--- a/04. Revision y retrospectiva/Revisión del Sprint.pptx
+++ b/04. Revision y retrospectiva/Revisión del Sprint.pptx
@@ -20662,7 +20662,7 @@
                 </a:solidFill>
                 <a:latin typeface="Calibri"/>
               </a:rPr>
-              <a:t>•  Pendientes del Sprint 1: firmar el acta y marcar HU01 a HU03 como terminadas en Trello</a:t>
+              <a:t>•  Sprint 1 concluido: las 4 historias (HU01 a HU04) están terminadas y el acta está firmada</a:t>
             </a:r>
           </a:p>
           <a:p>
@@ -22056,7 +22056,7 @@
                           </a:solidFill>
                           <a:latin typeface="Calibri"/>
                         </a:rPr>
-                        <a:t>Completada (acta por firmar)</a:t>
+                        <a:t>Completada (acta firmada)</a:t>
                       </a:r>
                     </a:p>
                   </a:txBody>
@@ -22124,7 +22124,7 @@
                           </a:solidFill>
                           <a:latin typeface="Calibri"/>
                         </a:rPr>
-                        <a:t>Completada (notebook ejecutado)</a:t>
+                        <a:t>Completada</a:t>
                       </a:r>
                     </a:p>
                   </a:txBody>
@@ -22192,7 +22192,7 @@
                           </a:solidFill>
                           <a:latin typeface="Calibri"/>
                         </a:rPr>
-                        <a:t>Completada (notebook ejecutado)</a:t>
+                        <a:t>Completada</a:t>
                       </a:r>
                     </a:p>
                   </a:txBody>
@@ -22260,7 +22260,7 @@
                           </a:solidFill>
                           <a:latin typeface="Calibri"/>
                         </a:rPr>
-                        <a:t>En curso (hoy)</a:t>
+                        <a:t>Completada</a:t>
                       </a:r>
                     </a:p>
                   </a:txBody>

</xml_diff>